<commit_message>
Fix negative shape width that made the requirements deck unopenable
Co-Authored-By: Claude Sonnet 5.5 <noreply@anthropic.com>
Claude-Session: https://claude.ai/code/session_01LHRcTHvJQmDsG7rmGwQkGp
</commit_message>
<xml_diff>
--- a/doc-mk/Requirements/requirements-overview.pptx
+++ b/doc-mk/Requirements/requirements-overview.pptx
@@ -5269,42 +5269,7 @@
       </p:sp>
       <p:sp>
         <p:nvSpPr>
-          <p:cNvPr id="15" name="TextBox 14"/>
-          <p:cNvSpPr txBox="1"/>
-          <p:nvPr/>
-        </p:nvSpPr>
-        <p:spPr>
-          <a:xfrm>
-            <a:off x="1307592" y="2606039"/>
-            <a:ext cx="-265176" cy="585216"/>
-          </a:xfrm>
-          <a:prstGeom prst="rect">
-            <a:avLst/>
-          </a:prstGeom>
-          <a:noFill/>
-        </p:spPr>
-        <p:txBody>
-          <a:bodyPr wrap="square" lIns="36576" tIns="18288" rIns="36576" bIns="18288" anchor="ctr">
-            <a:spAutoFit/>
-          </a:bodyPr>
-          <a:lstStyle/>
-          <a:p>
-            <a:pPr algn="l"/>
-            <a:r>
-              <a:rPr sz="1000" b="1" i="0">
-                <a:solidFill>
-                  <a:srgbClr val="000000"/>
-                </a:solidFill>
-                <a:latin typeface="맑은 고딕"/>
-              </a:rPr>
-              <a:t/>
-            </a:r>
-          </a:p>
-        </p:txBody>
-      </p:sp>
-      <p:sp>
-        <p:nvSpPr>
-          <p:cNvPr id="16" name="Rectangle 15"/>
+          <p:cNvPr id="15" name="Rectangle 14"/>
           <p:cNvSpPr/>
           <p:nvPr/>
         </p:nvSpPr>
@@ -5357,7 +5322,7 @@
       </p:sp>
       <p:sp>
         <p:nvSpPr>
-          <p:cNvPr id="17" name="Rectangle 16"/>
+          <p:cNvPr id="16" name="Rectangle 15"/>
           <p:cNvSpPr/>
           <p:nvPr/>
         </p:nvSpPr>
@@ -5410,7 +5375,7 @@
       </p:sp>
       <p:sp>
         <p:nvSpPr>
-          <p:cNvPr id="18" name="Rectangle 17"/>
+          <p:cNvPr id="17" name="Rectangle 16"/>
           <p:cNvSpPr/>
           <p:nvPr/>
         </p:nvSpPr>
@@ -5463,7 +5428,7 @@
       </p:sp>
       <p:sp>
         <p:nvSpPr>
-          <p:cNvPr id="19" name="Rectangle 18"/>
+          <p:cNvPr id="18" name="Rectangle 17"/>
           <p:cNvSpPr/>
           <p:nvPr/>
         </p:nvSpPr>
@@ -5516,7 +5481,7 @@
       </p:sp>
       <p:sp>
         <p:nvSpPr>
-          <p:cNvPr id="20" name="Rectangle 19"/>
+          <p:cNvPr id="19" name="Rectangle 18"/>
           <p:cNvSpPr/>
           <p:nvPr/>
         </p:nvSpPr>
@@ -5560,7 +5525,7 @@
       </p:sp>
       <p:sp>
         <p:nvSpPr>
-          <p:cNvPr id="21" name="Rectangle 20"/>
+          <p:cNvPr id="20" name="Rectangle 19"/>
           <p:cNvSpPr/>
           <p:nvPr/>
         </p:nvSpPr>
@@ -5604,7 +5569,7 @@
       </p:sp>
       <p:sp>
         <p:nvSpPr>
-          <p:cNvPr id="22" name="Rectangle 21"/>
+          <p:cNvPr id="21" name="Rectangle 20"/>
           <p:cNvSpPr/>
           <p:nvPr/>
         </p:nvSpPr>
@@ -5650,7 +5615,7 @@
       </p:sp>
       <p:sp>
         <p:nvSpPr>
-          <p:cNvPr id="23" name="Rectangle 22"/>
+          <p:cNvPr id="22" name="Rectangle 21"/>
           <p:cNvSpPr/>
           <p:nvPr/>
         </p:nvSpPr>
@@ -5694,7 +5659,7 @@
       </p:sp>
       <p:sp>
         <p:nvSpPr>
-          <p:cNvPr id="24" name="Oval 23"/>
+          <p:cNvPr id="23" name="Oval 22"/>
           <p:cNvSpPr/>
           <p:nvPr/>
         </p:nvSpPr>
@@ -5747,42 +5712,7 @@
       </p:sp>
       <p:sp>
         <p:nvSpPr>
-          <p:cNvPr id="25" name="TextBox 24"/>
-          <p:cNvSpPr txBox="1"/>
-          <p:nvPr/>
-        </p:nvSpPr>
-        <p:spPr>
-          <a:xfrm>
-            <a:off x="1307592" y="3264407"/>
-            <a:ext cx="-265176" cy="585216"/>
-          </a:xfrm>
-          <a:prstGeom prst="rect">
-            <a:avLst/>
-          </a:prstGeom>
-          <a:noFill/>
-        </p:spPr>
-        <p:txBody>
-          <a:bodyPr wrap="square" lIns="36576" tIns="18288" rIns="36576" bIns="18288" anchor="ctr">
-            <a:spAutoFit/>
-          </a:bodyPr>
-          <a:lstStyle/>
-          <a:p>
-            <a:pPr algn="l"/>
-            <a:r>
-              <a:rPr sz="1000" b="1" i="0">
-                <a:solidFill>
-                  <a:srgbClr val="000000"/>
-                </a:solidFill>
-                <a:latin typeface="맑은 고딕"/>
-              </a:rPr>
-              <a:t/>
-            </a:r>
-          </a:p>
-        </p:txBody>
-      </p:sp>
-      <p:sp>
-        <p:nvSpPr>
-          <p:cNvPr id="26" name="Rectangle 25"/>
+          <p:cNvPr id="24" name="Rectangle 23"/>
           <p:cNvSpPr/>
           <p:nvPr/>
         </p:nvSpPr>
@@ -5835,7 +5765,7 @@
       </p:sp>
       <p:sp>
         <p:nvSpPr>
-          <p:cNvPr id="27" name="Rectangle 26"/>
+          <p:cNvPr id="25" name="Rectangle 24"/>
           <p:cNvSpPr/>
           <p:nvPr/>
         </p:nvSpPr>
@@ -5888,7 +5818,7 @@
       </p:sp>
       <p:sp>
         <p:nvSpPr>
-          <p:cNvPr id="28" name="Rectangle 27"/>
+          <p:cNvPr id="26" name="Rectangle 25"/>
           <p:cNvSpPr/>
           <p:nvPr/>
         </p:nvSpPr>
@@ -5941,7 +5871,7 @@
       </p:sp>
       <p:sp>
         <p:nvSpPr>
-          <p:cNvPr id="29" name="Rectangle 28"/>
+          <p:cNvPr id="27" name="Rectangle 26"/>
           <p:cNvSpPr/>
           <p:nvPr/>
         </p:nvSpPr>
@@ -5994,7 +5924,7 @@
       </p:sp>
       <p:sp>
         <p:nvSpPr>
-          <p:cNvPr id="30" name="Rectangle 29"/>
+          <p:cNvPr id="28" name="Rectangle 27"/>
           <p:cNvSpPr/>
           <p:nvPr/>
         </p:nvSpPr>
@@ -6038,7 +5968,7 @@
       </p:sp>
       <p:sp>
         <p:nvSpPr>
-          <p:cNvPr id="31" name="Rectangle 30"/>
+          <p:cNvPr id="29" name="Rectangle 28"/>
           <p:cNvSpPr/>
           <p:nvPr/>
         </p:nvSpPr>
@@ -6082,7 +6012,7 @@
       </p:sp>
       <p:sp>
         <p:nvSpPr>
-          <p:cNvPr id="32" name="Rectangle 31"/>
+          <p:cNvPr id="30" name="Rectangle 29"/>
           <p:cNvSpPr/>
           <p:nvPr/>
         </p:nvSpPr>
@@ -6128,7 +6058,7 @@
       </p:sp>
       <p:sp>
         <p:nvSpPr>
-          <p:cNvPr id="33" name="Rectangle 32"/>
+          <p:cNvPr id="31" name="Rectangle 30"/>
           <p:cNvSpPr/>
           <p:nvPr/>
         </p:nvSpPr>
@@ -6172,7 +6102,7 @@
       </p:sp>
       <p:sp>
         <p:nvSpPr>
-          <p:cNvPr id="34" name="Oval 33"/>
+          <p:cNvPr id="32" name="Oval 31"/>
           <p:cNvSpPr/>
           <p:nvPr/>
         </p:nvSpPr>
@@ -6225,42 +6155,7 @@
       </p:sp>
       <p:sp>
         <p:nvSpPr>
-          <p:cNvPr id="35" name="TextBox 34"/>
-          <p:cNvSpPr txBox="1"/>
-          <p:nvPr/>
-        </p:nvSpPr>
-        <p:spPr>
-          <a:xfrm>
-            <a:off x="1307592" y="3922775"/>
-            <a:ext cx="-265176" cy="585216"/>
-          </a:xfrm>
-          <a:prstGeom prst="rect">
-            <a:avLst/>
-          </a:prstGeom>
-          <a:noFill/>
-        </p:spPr>
-        <p:txBody>
-          <a:bodyPr wrap="square" lIns="36576" tIns="18288" rIns="36576" bIns="18288" anchor="ctr">
-            <a:spAutoFit/>
-          </a:bodyPr>
-          <a:lstStyle/>
-          <a:p>
-            <a:pPr algn="l"/>
-            <a:r>
-              <a:rPr sz="1000" b="1" i="0">
-                <a:solidFill>
-                  <a:srgbClr val="000000"/>
-                </a:solidFill>
-                <a:latin typeface="맑은 고딕"/>
-              </a:rPr>
-              <a:t/>
-            </a:r>
-          </a:p>
-        </p:txBody>
-      </p:sp>
-      <p:sp>
-        <p:nvSpPr>
-          <p:cNvPr id="36" name="Rectangle 35"/>
+          <p:cNvPr id="33" name="Rectangle 32"/>
           <p:cNvSpPr/>
           <p:nvPr/>
         </p:nvSpPr>
@@ -6313,7 +6208,7 @@
       </p:sp>
       <p:sp>
         <p:nvSpPr>
-          <p:cNvPr id="37" name="Rectangle 36"/>
+          <p:cNvPr id="34" name="Rectangle 33"/>
           <p:cNvSpPr/>
           <p:nvPr/>
         </p:nvSpPr>
@@ -6366,7 +6261,7 @@
       </p:sp>
       <p:sp>
         <p:nvSpPr>
-          <p:cNvPr id="38" name="Rectangle 37"/>
+          <p:cNvPr id="35" name="Rectangle 34"/>
           <p:cNvSpPr/>
           <p:nvPr/>
         </p:nvSpPr>
@@ -6419,7 +6314,7 @@
       </p:sp>
       <p:sp>
         <p:nvSpPr>
-          <p:cNvPr id="39" name="Rectangle 38"/>
+          <p:cNvPr id="36" name="Rectangle 35"/>
           <p:cNvSpPr/>
           <p:nvPr/>
         </p:nvSpPr>
@@ -6472,7 +6367,7 @@
       </p:sp>
       <p:sp>
         <p:nvSpPr>
-          <p:cNvPr id="40" name="Rectangle 39"/>
+          <p:cNvPr id="37" name="Rectangle 36"/>
           <p:cNvSpPr/>
           <p:nvPr/>
         </p:nvSpPr>
@@ -6516,7 +6411,7 @@
       </p:sp>
       <p:sp>
         <p:nvSpPr>
-          <p:cNvPr id="41" name="Rectangle 40"/>
+          <p:cNvPr id="38" name="Rectangle 37"/>
           <p:cNvSpPr/>
           <p:nvPr/>
         </p:nvSpPr>
@@ -6560,7 +6455,7 @@
       </p:sp>
       <p:sp>
         <p:nvSpPr>
-          <p:cNvPr id="42" name="Rectangle 41"/>
+          <p:cNvPr id="39" name="Rectangle 38"/>
           <p:cNvSpPr/>
           <p:nvPr/>
         </p:nvSpPr>
@@ -6606,7 +6501,7 @@
       </p:sp>
       <p:sp>
         <p:nvSpPr>
-          <p:cNvPr id="43" name="Rectangle 42"/>
+          <p:cNvPr id="40" name="Rectangle 39"/>
           <p:cNvSpPr/>
           <p:nvPr/>
         </p:nvSpPr>
@@ -6650,7 +6545,7 @@
       </p:sp>
       <p:sp>
         <p:nvSpPr>
-          <p:cNvPr id="44" name="Oval 43"/>
+          <p:cNvPr id="41" name="Oval 40"/>
           <p:cNvSpPr/>
           <p:nvPr/>
         </p:nvSpPr>
@@ -6703,42 +6598,7 @@
       </p:sp>
       <p:sp>
         <p:nvSpPr>
-          <p:cNvPr id="45" name="TextBox 44"/>
-          <p:cNvSpPr txBox="1"/>
-          <p:nvPr/>
-        </p:nvSpPr>
-        <p:spPr>
-          <a:xfrm>
-            <a:off x="1307592" y="4581144"/>
-            <a:ext cx="-265176" cy="585216"/>
-          </a:xfrm>
-          <a:prstGeom prst="rect">
-            <a:avLst/>
-          </a:prstGeom>
-          <a:noFill/>
-        </p:spPr>
-        <p:txBody>
-          <a:bodyPr wrap="square" lIns="36576" tIns="18288" rIns="36576" bIns="18288" anchor="ctr">
-            <a:spAutoFit/>
-          </a:bodyPr>
-          <a:lstStyle/>
-          <a:p>
-            <a:pPr algn="l"/>
-            <a:r>
-              <a:rPr sz="1000" b="1" i="0">
-                <a:solidFill>
-                  <a:srgbClr val="000000"/>
-                </a:solidFill>
-                <a:latin typeface="맑은 고딕"/>
-              </a:rPr>
-              <a:t/>
-            </a:r>
-          </a:p>
-        </p:txBody>
-      </p:sp>
-      <p:sp>
-        <p:nvSpPr>
-          <p:cNvPr id="46" name="Rectangle 45"/>
+          <p:cNvPr id="42" name="Rectangle 41"/>
           <p:cNvSpPr/>
           <p:nvPr/>
         </p:nvSpPr>
@@ -6791,7 +6651,7 @@
       </p:sp>
       <p:sp>
         <p:nvSpPr>
-          <p:cNvPr id="47" name="Rectangle 46"/>
+          <p:cNvPr id="43" name="Rectangle 42"/>
           <p:cNvSpPr/>
           <p:nvPr/>
         </p:nvSpPr>
@@ -6844,7 +6704,7 @@
       </p:sp>
       <p:sp>
         <p:nvSpPr>
-          <p:cNvPr id="48" name="Rectangle 47"/>
+          <p:cNvPr id="44" name="Rectangle 43"/>
           <p:cNvSpPr/>
           <p:nvPr/>
         </p:nvSpPr>
@@ -6897,7 +6757,7 @@
       </p:sp>
       <p:sp>
         <p:nvSpPr>
-          <p:cNvPr id="49" name="Rectangle 48"/>
+          <p:cNvPr id="45" name="Rectangle 44"/>
           <p:cNvSpPr/>
           <p:nvPr/>
         </p:nvSpPr>
@@ -6950,7 +6810,7 @@
       </p:sp>
       <p:sp>
         <p:nvSpPr>
-          <p:cNvPr id="50" name="Rectangle 49"/>
+          <p:cNvPr id="46" name="Rectangle 45"/>
           <p:cNvSpPr/>
           <p:nvPr/>
         </p:nvSpPr>
@@ -6994,7 +6854,7 @@
       </p:sp>
       <p:sp>
         <p:nvSpPr>
-          <p:cNvPr id="51" name="Rectangle 50"/>
+          <p:cNvPr id="47" name="Rectangle 46"/>
           <p:cNvSpPr/>
           <p:nvPr/>
         </p:nvSpPr>
@@ -7038,7 +6898,7 @@
       </p:sp>
       <p:sp>
         <p:nvSpPr>
-          <p:cNvPr id="52" name="Rectangle 51"/>
+          <p:cNvPr id="48" name="Rectangle 47"/>
           <p:cNvSpPr/>
           <p:nvPr/>
         </p:nvSpPr>
@@ -7084,7 +6944,7 @@
       </p:sp>
       <p:sp>
         <p:nvSpPr>
-          <p:cNvPr id="53" name="Rectangle 52"/>
+          <p:cNvPr id="49" name="Rectangle 48"/>
           <p:cNvSpPr/>
           <p:nvPr/>
         </p:nvSpPr>
@@ -7128,7 +6988,7 @@
       </p:sp>
       <p:sp>
         <p:nvSpPr>
-          <p:cNvPr id="54" name="Oval 53"/>
+          <p:cNvPr id="50" name="Oval 49"/>
           <p:cNvSpPr/>
           <p:nvPr/>
         </p:nvSpPr>
@@ -7181,42 +7041,7 @@
       </p:sp>
       <p:sp>
         <p:nvSpPr>
-          <p:cNvPr id="55" name="TextBox 54"/>
-          <p:cNvSpPr txBox="1"/>
-          <p:nvPr/>
-        </p:nvSpPr>
-        <p:spPr>
-          <a:xfrm>
-            <a:off x="1307592" y="5239512"/>
-            <a:ext cx="-265176" cy="585216"/>
-          </a:xfrm>
-          <a:prstGeom prst="rect">
-            <a:avLst/>
-          </a:prstGeom>
-          <a:noFill/>
-        </p:spPr>
-        <p:txBody>
-          <a:bodyPr wrap="square" lIns="36576" tIns="18288" rIns="36576" bIns="18288" anchor="ctr">
-            <a:spAutoFit/>
-          </a:bodyPr>
-          <a:lstStyle/>
-          <a:p>
-            <a:pPr algn="l"/>
-            <a:r>
-              <a:rPr sz="1000" b="1" i="0">
-                <a:solidFill>
-                  <a:srgbClr val="000000"/>
-                </a:solidFill>
-                <a:latin typeface="맑은 고딕"/>
-              </a:rPr>
-              <a:t/>
-            </a:r>
-          </a:p>
-        </p:txBody>
-      </p:sp>
-      <p:sp>
-        <p:nvSpPr>
-          <p:cNvPr id="56" name="Rectangle 55"/>
+          <p:cNvPr id="51" name="Rectangle 50"/>
           <p:cNvSpPr/>
           <p:nvPr/>
         </p:nvSpPr>
@@ -7269,7 +7094,7 @@
       </p:sp>
       <p:sp>
         <p:nvSpPr>
-          <p:cNvPr id="57" name="Rectangle 56"/>
+          <p:cNvPr id="52" name="Rectangle 51"/>
           <p:cNvSpPr/>
           <p:nvPr/>
         </p:nvSpPr>
@@ -7322,7 +7147,7 @@
       </p:sp>
       <p:sp>
         <p:nvSpPr>
-          <p:cNvPr id="58" name="Rectangle 57"/>
+          <p:cNvPr id="53" name="Rectangle 52"/>
           <p:cNvSpPr/>
           <p:nvPr/>
         </p:nvSpPr>
@@ -7375,7 +7200,7 @@
       </p:sp>
       <p:sp>
         <p:nvSpPr>
-          <p:cNvPr id="59" name="Rectangle 58"/>
+          <p:cNvPr id="54" name="Rectangle 53"/>
           <p:cNvSpPr/>
           <p:nvPr/>
         </p:nvSpPr>
@@ -7428,7 +7253,7 @@
       </p:sp>
       <p:sp>
         <p:nvSpPr>
-          <p:cNvPr id="60" name="Rectangle 59"/>
+          <p:cNvPr id="55" name="Rectangle 54"/>
           <p:cNvSpPr/>
           <p:nvPr/>
         </p:nvSpPr>
@@ -7472,7 +7297,7 @@
       </p:sp>
       <p:sp>
         <p:nvSpPr>
-          <p:cNvPr id="61" name="Rectangle 60"/>
+          <p:cNvPr id="56" name="Rectangle 55"/>
           <p:cNvSpPr/>
           <p:nvPr/>
         </p:nvSpPr>
@@ -7516,7 +7341,7 @@
       </p:sp>
       <p:sp>
         <p:nvSpPr>
-          <p:cNvPr id="62" name="Rectangle 61"/>
+          <p:cNvPr id="57" name="Rectangle 56"/>
           <p:cNvSpPr/>
           <p:nvPr/>
         </p:nvSpPr>
@@ -7562,7 +7387,7 @@
       </p:sp>
       <p:sp>
         <p:nvSpPr>
-          <p:cNvPr id="63" name="Rectangle 62"/>
+          <p:cNvPr id="58" name="Rectangle 57"/>
           <p:cNvSpPr/>
           <p:nvPr/>
         </p:nvSpPr>
@@ -7606,7 +7431,7 @@
       </p:sp>
       <p:sp>
         <p:nvSpPr>
-          <p:cNvPr id="64" name="Oval 63"/>
+          <p:cNvPr id="59" name="Oval 58"/>
           <p:cNvSpPr/>
           <p:nvPr/>
         </p:nvSpPr>
@@ -7659,42 +7484,7 @@
       </p:sp>
       <p:sp>
         <p:nvSpPr>
-          <p:cNvPr id="65" name="TextBox 64"/>
-          <p:cNvSpPr txBox="1"/>
-          <p:nvPr/>
-        </p:nvSpPr>
-        <p:spPr>
-          <a:xfrm>
-            <a:off x="1307592" y="5897879"/>
-            <a:ext cx="-265176" cy="585216"/>
-          </a:xfrm>
-          <a:prstGeom prst="rect">
-            <a:avLst/>
-          </a:prstGeom>
-          <a:noFill/>
-        </p:spPr>
-        <p:txBody>
-          <a:bodyPr wrap="square" lIns="36576" tIns="18288" rIns="36576" bIns="18288" anchor="ctr">
-            <a:spAutoFit/>
-          </a:bodyPr>
-          <a:lstStyle/>
-          <a:p>
-            <a:pPr algn="l"/>
-            <a:r>
-              <a:rPr sz="1000" b="1" i="0">
-                <a:solidFill>
-                  <a:srgbClr val="000000"/>
-                </a:solidFill>
-                <a:latin typeface="맑은 고딕"/>
-              </a:rPr>
-              <a:t/>
-            </a:r>
-          </a:p>
-        </p:txBody>
-      </p:sp>
-      <p:sp>
-        <p:nvSpPr>
-          <p:cNvPr id="66" name="Rectangle 65"/>
+          <p:cNvPr id="60" name="Rectangle 59"/>
           <p:cNvSpPr/>
           <p:nvPr/>
         </p:nvSpPr>
@@ -7747,7 +7537,7 @@
       </p:sp>
       <p:sp>
         <p:nvSpPr>
-          <p:cNvPr id="67" name="Rectangle 66"/>
+          <p:cNvPr id="61" name="Rectangle 60"/>
           <p:cNvSpPr/>
           <p:nvPr/>
         </p:nvSpPr>
@@ -7800,7 +7590,7 @@
       </p:sp>
       <p:sp>
         <p:nvSpPr>
-          <p:cNvPr id="68" name="Rectangle 67"/>
+          <p:cNvPr id="62" name="Rectangle 61"/>
           <p:cNvSpPr/>
           <p:nvPr/>
         </p:nvSpPr>
@@ -7853,7 +7643,7 @@
       </p:sp>
       <p:sp>
         <p:nvSpPr>
-          <p:cNvPr id="69" name="Rectangle 68"/>
+          <p:cNvPr id="63" name="Rectangle 62"/>
           <p:cNvSpPr/>
           <p:nvPr/>
         </p:nvSpPr>
@@ -7906,7 +7696,7 @@
       </p:sp>
       <p:sp>
         <p:nvSpPr>
-          <p:cNvPr id="70" name="Rectangle 69"/>
+          <p:cNvPr id="64" name="Rectangle 63"/>
           <p:cNvSpPr/>
           <p:nvPr/>
         </p:nvSpPr>
@@ -7950,7 +7740,7 @@
       </p:sp>
       <p:sp>
         <p:nvSpPr>
-          <p:cNvPr id="71" name="Rectangle 70"/>
+          <p:cNvPr id="65" name="Rectangle 64"/>
           <p:cNvSpPr/>
           <p:nvPr/>
         </p:nvSpPr>
@@ -15255,41 +15045,6 @@
         </p:nvSpPr>
         <p:spPr>
           <a:xfrm>
-            <a:off x="1133856" y="1051560"/>
-            <a:ext cx="1700784" cy="402336"/>
-          </a:xfrm>
-          <a:prstGeom prst="rect">
-            <a:avLst/>
-          </a:prstGeom>
-          <a:noFill/>
-        </p:spPr>
-        <p:txBody>
-          <a:bodyPr wrap="square" lIns="36576" tIns="18288" rIns="36576" bIns="18288" anchor="ctr">
-            <a:spAutoFit/>
-          </a:bodyPr>
-          <a:lstStyle/>
-          <a:p>
-            <a:pPr algn="l"/>
-            <a:r>
-              <a:rPr sz="1000" b="1" i="0">
-                <a:solidFill>
-                  <a:srgbClr val="000000"/>
-                </a:solidFill>
-                <a:latin typeface="맑은 고딕"/>
-              </a:rPr>
-              <a:t/>
-            </a:r>
-          </a:p>
-        </p:txBody>
-      </p:sp>
-      <p:sp>
-        <p:nvSpPr>
-          <p:cNvPr id="12" name="TextBox 11"/>
-          <p:cNvSpPr txBox="1"/>
-          <p:nvPr/>
-        </p:nvSpPr>
-        <p:spPr>
-          <a:xfrm>
             <a:off x="1143000" y="1051560"/>
             <a:ext cx="1783080" cy="402336"/>
           </a:xfrm>
@@ -15319,7 +15074,7 @@
       </p:sp>
       <p:sp>
         <p:nvSpPr>
-          <p:cNvPr id="13" name="Rectangle 12"/>
+          <p:cNvPr id="12" name="Rectangle 11"/>
           <p:cNvSpPr/>
           <p:nvPr/>
         </p:nvSpPr>
@@ -15365,7 +15120,7 @@
       </p:sp>
       <p:sp>
         <p:nvSpPr>
-          <p:cNvPr id="14" name="Rectangle 13"/>
+          <p:cNvPr id="13" name="Rectangle 12"/>
           <p:cNvSpPr/>
           <p:nvPr/>
         </p:nvSpPr>
@@ -15409,7 +15164,7 @@
       </p:sp>
       <p:sp>
         <p:nvSpPr>
-          <p:cNvPr id="15" name="Oval 14"/>
+          <p:cNvPr id="14" name="Oval 13"/>
           <p:cNvSpPr/>
           <p:nvPr/>
         </p:nvSpPr>
@@ -15462,42 +15217,7 @@
       </p:sp>
       <p:sp>
         <p:nvSpPr>
-          <p:cNvPr id="16" name="TextBox 15"/>
-          <p:cNvSpPr txBox="1"/>
-          <p:nvPr/>
-        </p:nvSpPr>
-        <p:spPr>
-          <a:xfrm>
-            <a:off x="3877056" y="1051560"/>
-            <a:ext cx="1700784" cy="402336"/>
-          </a:xfrm>
-          <a:prstGeom prst="rect">
-            <a:avLst/>
-          </a:prstGeom>
-          <a:noFill/>
-        </p:spPr>
-        <p:txBody>
-          <a:bodyPr wrap="square" lIns="36576" tIns="18288" rIns="36576" bIns="18288" anchor="ctr">
-            <a:spAutoFit/>
-          </a:bodyPr>
-          <a:lstStyle/>
-          <a:p>
-            <a:pPr algn="l"/>
-            <a:r>
-              <a:rPr sz="1000" b="1" i="0">
-                <a:solidFill>
-                  <a:srgbClr val="000000"/>
-                </a:solidFill>
-                <a:latin typeface="맑은 고딕"/>
-              </a:rPr>
-              <a:t/>
-            </a:r>
-          </a:p>
-        </p:txBody>
-      </p:sp>
-      <p:sp>
-        <p:nvSpPr>
-          <p:cNvPr id="17" name="TextBox 16"/>
+          <p:cNvPr id="15" name="TextBox 14"/>
           <p:cNvSpPr txBox="1"/>
           <p:nvPr/>
         </p:nvSpPr>
@@ -15532,7 +15252,7 @@
       </p:sp>
       <p:sp>
         <p:nvSpPr>
-          <p:cNvPr id="18" name="Rectangle 17"/>
+          <p:cNvPr id="16" name="Rectangle 15"/>
           <p:cNvSpPr/>
           <p:nvPr/>
         </p:nvSpPr>
@@ -15578,7 +15298,7 @@
       </p:sp>
       <p:sp>
         <p:nvSpPr>
-          <p:cNvPr id="19" name="Rectangle 18"/>
+          <p:cNvPr id="17" name="Rectangle 16"/>
           <p:cNvSpPr/>
           <p:nvPr/>
         </p:nvSpPr>
@@ -15622,7 +15342,7 @@
       </p:sp>
       <p:sp>
         <p:nvSpPr>
-          <p:cNvPr id="20" name="Oval 19"/>
+          <p:cNvPr id="18" name="Oval 17"/>
           <p:cNvSpPr/>
           <p:nvPr/>
         </p:nvSpPr>
@@ -15675,42 +15395,7 @@
       </p:sp>
       <p:sp>
         <p:nvSpPr>
-          <p:cNvPr id="21" name="TextBox 20"/>
-          <p:cNvSpPr txBox="1"/>
-          <p:nvPr/>
-        </p:nvSpPr>
-        <p:spPr>
-          <a:xfrm>
-            <a:off x="1133856" y="1527048"/>
-            <a:ext cx="1700784" cy="402336"/>
-          </a:xfrm>
-          <a:prstGeom prst="rect">
-            <a:avLst/>
-          </a:prstGeom>
-          <a:noFill/>
-        </p:spPr>
-        <p:txBody>
-          <a:bodyPr wrap="square" lIns="36576" tIns="18288" rIns="36576" bIns="18288" anchor="ctr">
-            <a:spAutoFit/>
-          </a:bodyPr>
-          <a:lstStyle/>
-          <a:p>
-            <a:pPr algn="l"/>
-            <a:r>
-              <a:rPr sz="1000" b="1" i="0">
-                <a:solidFill>
-                  <a:srgbClr val="000000"/>
-                </a:solidFill>
-                <a:latin typeface="맑은 고딕"/>
-              </a:rPr>
-              <a:t/>
-            </a:r>
-          </a:p>
-        </p:txBody>
-      </p:sp>
-      <p:sp>
-        <p:nvSpPr>
-          <p:cNvPr id="22" name="TextBox 21"/>
+          <p:cNvPr id="19" name="TextBox 18"/>
           <p:cNvSpPr txBox="1"/>
           <p:nvPr/>
         </p:nvSpPr>
@@ -15745,7 +15430,7 @@
       </p:sp>
       <p:sp>
         <p:nvSpPr>
-          <p:cNvPr id="23" name="Rectangle 22"/>
+          <p:cNvPr id="20" name="Rectangle 19"/>
           <p:cNvSpPr/>
           <p:nvPr/>
         </p:nvSpPr>
@@ -15791,7 +15476,7 @@
       </p:sp>
       <p:sp>
         <p:nvSpPr>
-          <p:cNvPr id="24" name="Rectangle 23"/>
+          <p:cNvPr id="21" name="Rectangle 20"/>
           <p:cNvSpPr/>
           <p:nvPr/>
         </p:nvSpPr>
@@ -15835,7 +15520,7 @@
       </p:sp>
       <p:sp>
         <p:nvSpPr>
-          <p:cNvPr id="25" name="Oval 24"/>
+          <p:cNvPr id="22" name="Oval 21"/>
           <p:cNvSpPr/>
           <p:nvPr/>
         </p:nvSpPr>
@@ -15888,42 +15573,7 @@
       </p:sp>
       <p:sp>
         <p:nvSpPr>
-          <p:cNvPr id="26" name="TextBox 25"/>
-          <p:cNvSpPr txBox="1"/>
-          <p:nvPr/>
-        </p:nvSpPr>
-        <p:spPr>
-          <a:xfrm>
-            <a:off x="3877056" y="1527048"/>
-            <a:ext cx="1700784" cy="402336"/>
-          </a:xfrm>
-          <a:prstGeom prst="rect">
-            <a:avLst/>
-          </a:prstGeom>
-          <a:noFill/>
-        </p:spPr>
-        <p:txBody>
-          <a:bodyPr wrap="square" lIns="36576" tIns="18288" rIns="36576" bIns="18288" anchor="ctr">
-            <a:spAutoFit/>
-          </a:bodyPr>
-          <a:lstStyle/>
-          <a:p>
-            <a:pPr algn="l"/>
-            <a:r>
-              <a:rPr sz="1000" b="1" i="0">
-                <a:solidFill>
-                  <a:srgbClr val="000000"/>
-                </a:solidFill>
-                <a:latin typeface="맑은 고딕"/>
-              </a:rPr>
-              <a:t/>
-            </a:r>
-          </a:p>
-        </p:txBody>
-      </p:sp>
-      <p:sp>
-        <p:nvSpPr>
-          <p:cNvPr id="27" name="TextBox 26"/>
+          <p:cNvPr id="23" name="TextBox 22"/>
           <p:cNvSpPr txBox="1"/>
           <p:nvPr/>
         </p:nvSpPr>
@@ -15958,7 +15608,7 @@
       </p:sp>
       <p:sp>
         <p:nvSpPr>
-          <p:cNvPr id="28" name="Rectangle 27"/>
+          <p:cNvPr id="24" name="Rectangle 23"/>
           <p:cNvSpPr/>
           <p:nvPr/>
         </p:nvSpPr>
@@ -16004,7 +15654,7 @@
       </p:sp>
       <p:sp>
         <p:nvSpPr>
-          <p:cNvPr id="29" name="Rectangle 28"/>
+          <p:cNvPr id="25" name="Rectangle 24"/>
           <p:cNvSpPr/>
           <p:nvPr/>
         </p:nvSpPr>
@@ -16048,7 +15698,7 @@
       </p:sp>
       <p:sp>
         <p:nvSpPr>
-          <p:cNvPr id="30" name="Oval 29"/>
+          <p:cNvPr id="26" name="Oval 25"/>
           <p:cNvSpPr/>
           <p:nvPr/>
         </p:nvSpPr>
@@ -16101,42 +15751,7 @@
       </p:sp>
       <p:sp>
         <p:nvSpPr>
-          <p:cNvPr id="31" name="TextBox 30"/>
-          <p:cNvSpPr txBox="1"/>
-          <p:nvPr/>
-        </p:nvSpPr>
-        <p:spPr>
-          <a:xfrm>
-            <a:off x="1133856" y="2002536"/>
-            <a:ext cx="1700784" cy="402336"/>
-          </a:xfrm>
-          <a:prstGeom prst="rect">
-            <a:avLst/>
-          </a:prstGeom>
-          <a:noFill/>
-        </p:spPr>
-        <p:txBody>
-          <a:bodyPr wrap="square" lIns="36576" tIns="18288" rIns="36576" bIns="18288" anchor="ctr">
-            <a:spAutoFit/>
-          </a:bodyPr>
-          <a:lstStyle/>
-          <a:p>
-            <a:pPr algn="l"/>
-            <a:r>
-              <a:rPr sz="1000" b="1" i="0">
-                <a:solidFill>
-                  <a:srgbClr val="000000"/>
-                </a:solidFill>
-                <a:latin typeface="맑은 고딕"/>
-              </a:rPr>
-              <a:t/>
-            </a:r>
-          </a:p>
-        </p:txBody>
-      </p:sp>
-      <p:sp>
-        <p:nvSpPr>
-          <p:cNvPr id="32" name="TextBox 31"/>
+          <p:cNvPr id="27" name="TextBox 26"/>
           <p:cNvSpPr txBox="1"/>
           <p:nvPr/>
         </p:nvSpPr>
@@ -16171,7 +15786,7 @@
       </p:sp>
       <p:sp>
         <p:nvSpPr>
-          <p:cNvPr id="33" name="Rectangle 32"/>
+          <p:cNvPr id="28" name="Rectangle 27"/>
           <p:cNvSpPr/>
           <p:nvPr/>
         </p:nvSpPr>
@@ -16217,7 +15832,7 @@
       </p:sp>
       <p:sp>
         <p:nvSpPr>
-          <p:cNvPr id="34" name="Rectangle 33"/>
+          <p:cNvPr id="29" name="Rectangle 28"/>
           <p:cNvSpPr/>
           <p:nvPr/>
         </p:nvSpPr>
@@ -16261,7 +15876,7 @@
       </p:sp>
       <p:sp>
         <p:nvSpPr>
-          <p:cNvPr id="35" name="Oval 34"/>
+          <p:cNvPr id="30" name="Oval 29"/>
           <p:cNvSpPr/>
           <p:nvPr/>
         </p:nvSpPr>
@@ -16314,42 +15929,7 @@
       </p:sp>
       <p:sp>
         <p:nvSpPr>
-          <p:cNvPr id="36" name="TextBox 35"/>
-          <p:cNvSpPr txBox="1"/>
-          <p:nvPr/>
-        </p:nvSpPr>
-        <p:spPr>
-          <a:xfrm>
-            <a:off x="3877056" y="2002536"/>
-            <a:ext cx="1700784" cy="402336"/>
-          </a:xfrm>
-          <a:prstGeom prst="rect">
-            <a:avLst/>
-          </a:prstGeom>
-          <a:noFill/>
-        </p:spPr>
-        <p:txBody>
-          <a:bodyPr wrap="square" lIns="36576" tIns="18288" rIns="36576" bIns="18288" anchor="ctr">
-            <a:spAutoFit/>
-          </a:bodyPr>
-          <a:lstStyle/>
-          <a:p>
-            <a:pPr algn="l"/>
-            <a:r>
-              <a:rPr sz="1000" b="1" i="0">
-                <a:solidFill>
-                  <a:srgbClr val="000000"/>
-                </a:solidFill>
-                <a:latin typeface="맑은 고딕"/>
-              </a:rPr>
-              <a:t/>
-            </a:r>
-          </a:p>
-        </p:txBody>
-      </p:sp>
-      <p:sp>
-        <p:nvSpPr>
-          <p:cNvPr id="37" name="TextBox 36"/>
+          <p:cNvPr id="31" name="TextBox 30"/>
           <p:cNvSpPr txBox="1"/>
           <p:nvPr/>
         </p:nvSpPr>
@@ -16384,7 +15964,7 @@
       </p:sp>
       <p:sp>
         <p:nvSpPr>
-          <p:cNvPr id="38" name="Rectangle 37"/>
+          <p:cNvPr id="32" name="Rectangle 31"/>
           <p:cNvSpPr/>
           <p:nvPr/>
         </p:nvSpPr>
@@ -16430,7 +16010,7 @@
       </p:sp>
       <p:sp>
         <p:nvSpPr>
-          <p:cNvPr id="39" name="Rectangle 38"/>
+          <p:cNvPr id="33" name="Rectangle 32"/>
           <p:cNvSpPr/>
           <p:nvPr/>
         </p:nvSpPr>
@@ -16474,7 +16054,7 @@
       </p:sp>
       <p:sp>
         <p:nvSpPr>
-          <p:cNvPr id="40" name="Oval 39"/>
+          <p:cNvPr id="34" name="Oval 33"/>
           <p:cNvSpPr/>
           <p:nvPr/>
         </p:nvSpPr>
@@ -16527,42 +16107,7 @@
       </p:sp>
       <p:sp>
         <p:nvSpPr>
-          <p:cNvPr id="41" name="TextBox 40"/>
-          <p:cNvSpPr txBox="1"/>
-          <p:nvPr/>
-        </p:nvSpPr>
-        <p:spPr>
-          <a:xfrm>
-            <a:off x="1133856" y="2478024"/>
-            <a:ext cx="1700784" cy="402336"/>
-          </a:xfrm>
-          <a:prstGeom prst="rect">
-            <a:avLst/>
-          </a:prstGeom>
-          <a:noFill/>
-        </p:spPr>
-        <p:txBody>
-          <a:bodyPr wrap="square" lIns="36576" tIns="18288" rIns="36576" bIns="18288" anchor="ctr">
-            <a:spAutoFit/>
-          </a:bodyPr>
-          <a:lstStyle/>
-          <a:p>
-            <a:pPr algn="l"/>
-            <a:r>
-              <a:rPr sz="1000" b="1" i="0">
-                <a:solidFill>
-                  <a:srgbClr val="000000"/>
-                </a:solidFill>
-                <a:latin typeface="맑은 고딕"/>
-              </a:rPr>
-              <a:t/>
-            </a:r>
-          </a:p>
-        </p:txBody>
-      </p:sp>
-      <p:sp>
-        <p:nvSpPr>
-          <p:cNvPr id="42" name="TextBox 41"/>
+          <p:cNvPr id="35" name="TextBox 34"/>
           <p:cNvSpPr txBox="1"/>
           <p:nvPr/>
         </p:nvSpPr>
@@ -16597,7 +16142,7 @@
       </p:sp>
       <p:sp>
         <p:nvSpPr>
-          <p:cNvPr id="43" name="Rectangle 42"/>
+          <p:cNvPr id="36" name="Rectangle 35"/>
           <p:cNvSpPr/>
           <p:nvPr/>
         </p:nvSpPr>
@@ -16643,7 +16188,7 @@
       </p:sp>
       <p:sp>
         <p:nvSpPr>
-          <p:cNvPr id="44" name="Rectangle 43"/>
+          <p:cNvPr id="37" name="Rectangle 36"/>
           <p:cNvSpPr/>
           <p:nvPr/>
         </p:nvSpPr>
@@ -16687,7 +16232,7 @@
       </p:sp>
       <p:sp>
         <p:nvSpPr>
-          <p:cNvPr id="45" name="Oval 44"/>
+          <p:cNvPr id="38" name="Oval 37"/>
           <p:cNvSpPr/>
           <p:nvPr/>
         </p:nvSpPr>
@@ -16740,42 +16285,7 @@
       </p:sp>
       <p:sp>
         <p:nvSpPr>
-          <p:cNvPr id="46" name="TextBox 45"/>
-          <p:cNvSpPr txBox="1"/>
-          <p:nvPr/>
-        </p:nvSpPr>
-        <p:spPr>
-          <a:xfrm>
-            <a:off x="3877056" y="2478024"/>
-            <a:ext cx="1700784" cy="402336"/>
-          </a:xfrm>
-          <a:prstGeom prst="rect">
-            <a:avLst/>
-          </a:prstGeom>
-          <a:noFill/>
-        </p:spPr>
-        <p:txBody>
-          <a:bodyPr wrap="square" lIns="36576" tIns="18288" rIns="36576" bIns="18288" anchor="ctr">
-            <a:spAutoFit/>
-          </a:bodyPr>
-          <a:lstStyle/>
-          <a:p>
-            <a:pPr algn="l"/>
-            <a:r>
-              <a:rPr sz="1000" b="1" i="0">
-                <a:solidFill>
-                  <a:srgbClr val="000000"/>
-                </a:solidFill>
-                <a:latin typeface="맑은 고딕"/>
-              </a:rPr>
-              <a:t/>
-            </a:r>
-          </a:p>
-        </p:txBody>
-      </p:sp>
-      <p:sp>
-        <p:nvSpPr>
-          <p:cNvPr id="47" name="TextBox 46"/>
+          <p:cNvPr id="39" name="TextBox 38"/>
           <p:cNvSpPr txBox="1"/>
           <p:nvPr/>
         </p:nvSpPr>
@@ -16810,7 +16320,7 @@
       </p:sp>
       <p:sp>
         <p:nvSpPr>
-          <p:cNvPr id="48" name="Rectangle 47"/>
+          <p:cNvPr id="40" name="Rectangle 39"/>
           <p:cNvSpPr/>
           <p:nvPr/>
         </p:nvSpPr>
@@ -16856,7 +16366,7 @@
       </p:sp>
       <p:sp>
         <p:nvSpPr>
-          <p:cNvPr id="49" name="Rectangle 48"/>
+          <p:cNvPr id="41" name="Rectangle 40"/>
           <p:cNvSpPr/>
           <p:nvPr/>
         </p:nvSpPr>
@@ -16900,7 +16410,7 @@
       </p:sp>
       <p:sp>
         <p:nvSpPr>
-          <p:cNvPr id="50" name="Oval 49"/>
+          <p:cNvPr id="42" name="Oval 41"/>
           <p:cNvSpPr/>
           <p:nvPr/>
         </p:nvSpPr>
@@ -16953,42 +16463,7 @@
       </p:sp>
       <p:sp>
         <p:nvSpPr>
-          <p:cNvPr id="51" name="TextBox 50"/>
-          <p:cNvSpPr txBox="1"/>
-          <p:nvPr/>
-        </p:nvSpPr>
-        <p:spPr>
-          <a:xfrm>
-            <a:off x="1133856" y="2953512"/>
-            <a:ext cx="1700784" cy="402336"/>
-          </a:xfrm>
-          <a:prstGeom prst="rect">
-            <a:avLst/>
-          </a:prstGeom>
-          <a:noFill/>
-        </p:spPr>
-        <p:txBody>
-          <a:bodyPr wrap="square" lIns="36576" tIns="18288" rIns="36576" bIns="18288" anchor="ctr">
-            <a:spAutoFit/>
-          </a:bodyPr>
-          <a:lstStyle/>
-          <a:p>
-            <a:pPr algn="l"/>
-            <a:r>
-              <a:rPr sz="1000" b="1" i="0">
-                <a:solidFill>
-                  <a:srgbClr val="000000"/>
-                </a:solidFill>
-                <a:latin typeface="맑은 고딕"/>
-              </a:rPr>
-              <a:t/>
-            </a:r>
-          </a:p>
-        </p:txBody>
-      </p:sp>
-      <p:sp>
-        <p:nvSpPr>
-          <p:cNvPr id="52" name="TextBox 51"/>
+          <p:cNvPr id="43" name="TextBox 42"/>
           <p:cNvSpPr txBox="1"/>
           <p:nvPr/>
         </p:nvSpPr>
@@ -17023,7 +16498,7 @@
       </p:sp>
       <p:sp>
         <p:nvSpPr>
-          <p:cNvPr id="53" name="Rectangle 52"/>
+          <p:cNvPr id="44" name="Rectangle 43"/>
           <p:cNvSpPr/>
           <p:nvPr/>
         </p:nvSpPr>
@@ -17069,7 +16544,7 @@
       </p:sp>
       <p:sp>
         <p:nvSpPr>
-          <p:cNvPr id="54" name="Rectangle 53"/>
+          <p:cNvPr id="45" name="Rectangle 44"/>
           <p:cNvSpPr/>
           <p:nvPr/>
         </p:nvSpPr>
@@ -17113,7 +16588,7 @@
       </p:sp>
       <p:sp>
         <p:nvSpPr>
-          <p:cNvPr id="55" name="Oval 54"/>
+          <p:cNvPr id="46" name="Oval 45"/>
           <p:cNvSpPr/>
           <p:nvPr/>
         </p:nvSpPr>
@@ -17166,42 +16641,7 @@
       </p:sp>
       <p:sp>
         <p:nvSpPr>
-          <p:cNvPr id="56" name="TextBox 55"/>
-          <p:cNvSpPr txBox="1"/>
-          <p:nvPr/>
-        </p:nvSpPr>
-        <p:spPr>
-          <a:xfrm>
-            <a:off x="3877056" y="2953512"/>
-            <a:ext cx="1700784" cy="402336"/>
-          </a:xfrm>
-          <a:prstGeom prst="rect">
-            <a:avLst/>
-          </a:prstGeom>
-          <a:noFill/>
-        </p:spPr>
-        <p:txBody>
-          <a:bodyPr wrap="square" lIns="36576" tIns="18288" rIns="36576" bIns="18288" anchor="ctr">
-            <a:spAutoFit/>
-          </a:bodyPr>
-          <a:lstStyle/>
-          <a:p>
-            <a:pPr algn="l"/>
-            <a:r>
-              <a:rPr sz="1000" b="1" i="0">
-                <a:solidFill>
-                  <a:srgbClr val="000000"/>
-                </a:solidFill>
-                <a:latin typeface="맑은 고딕"/>
-              </a:rPr>
-              <a:t/>
-            </a:r>
-          </a:p>
-        </p:txBody>
-      </p:sp>
-      <p:sp>
-        <p:nvSpPr>
-          <p:cNvPr id="57" name="TextBox 56"/>
+          <p:cNvPr id="47" name="TextBox 46"/>
           <p:cNvSpPr txBox="1"/>
           <p:nvPr/>
         </p:nvSpPr>
@@ -17236,7 +16676,7 @@
       </p:sp>
       <p:sp>
         <p:nvSpPr>
-          <p:cNvPr id="58" name="Rectangle 57"/>
+          <p:cNvPr id="48" name="Rectangle 47"/>
           <p:cNvSpPr/>
           <p:nvPr/>
         </p:nvSpPr>
@@ -17282,7 +16722,7 @@
       </p:sp>
       <p:sp>
         <p:nvSpPr>
-          <p:cNvPr id="59" name="Rectangle 58"/>
+          <p:cNvPr id="49" name="Rectangle 48"/>
           <p:cNvSpPr/>
           <p:nvPr/>
         </p:nvSpPr>
@@ -17326,7 +16766,7 @@
       </p:sp>
       <p:sp>
         <p:nvSpPr>
-          <p:cNvPr id="60" name="Oval 59"/>
+          <p:cNvPr id="50" name="Oval 49"/>
           <p:cNvSpPr/>
           <p:nvPr/>
         </p:nvSpPr>
@@ -17379,42 +16819,7 @@
       </p:sp>
       <p:sp>
         <p:nvSpPr>
-          <p:cNvPr id="61" name="TextBox 60"/>
-          <p:cNvSpPr txBox="1"/>
-          <p:nvPr/>
-        </p:nvSpPr>
-        <p:spPr>
-          <a:xfrm>
-            <a:off x="9363456" y="1051560"/>
-            <a:ext cx="2478024" cy="402336"/>
-          </a:xfrm>
-          <a:prstGeom prst="rect">
-            <a:avLst/>
-          </a:prstGeom>
-          <a:noFill/>
-        </p:spPr>
-        <p:txBody>
-          <a:bodyPr wrap="square" lIns="36576" tIns="18288" rIns="36576" bIns="18288" anchor="ctr">
-            <a:spAutoFit/>
-          </a:bodyPr>
-          <a:lstStyle/>
-          <a:p>
-            <a:pPr algn="l"/>
-            <a:r>
-              <a:rPr sz="1000" b="1" i="0">
-                <a:solidFill>
-                  <a:srgbClr val="000000"/>
-                </a:solidFill>
-                <a:latin typeface="맑은 고딕"/>
-              </a:rPr>
-              <a:t/>
-            </a:r>
-          </a:p>
-        </p:txBody>
-      </p:sp>
-      <p:sp>
-        <p:nvSpPr>
-          <p:cNvPr id="62" name="TextBox 61"/>
+          <p:cNvPr id="51" name="TextBox 50"/>
           <p:cNvSpPr txBox="1"/>
           <p:nvPr/>
         </p:nvSpPr>
@@ -17449,7 +16854,7 @@
       </p:sp>
       <p:sp>
         <p:nvSpPr>
-          <p:cNvPr id="63" name="Rectangle 62"/>
+          <p:cNvPr id="52" name="Rectangle 51"/>
           <p:cNvSpPr/>
           <p:nvPr/>
         </p:nvSpPr>
@@ -17495,7 +16900,7 @@
       </p:sp>
       <p:sp>
         <p:nvSpPr>
-          <p:cNvPr id="64" name="Rectangle 63"/>
+          <p:cNvPr id="53" name="Rectangle 52"/>
           <p:cNvSpPr/>
           <p:nvPr/>
         </p:nvSpPr>
@@ -17539,7 +16944,7 @@
       </p:sp>
       <p:sp>
         <p:nvSpPr>
-          <p:cNvPr id="65" name="Oval 64"/>
+          <p:cNvPr id="54" name="Oval 53"/>
           <p:cNvSpPr/>
           <p:nvPr/>
         </p:nvSpPr>
@@ -17592,42 +16997,7 @@
       </p:sp>
       <p:sp>
         <p:nvSpPr>
-          <p:cNvPr id="66" name="TextBox 65"/>
-          <p:cNvSpPr txBox="1"/>
-          <p:nvPr/>
-        </p:nvSpPr>
-        <p:spPr>
-          <a:xfrm>
-            <a:off x="9363456" y="1527048"/>
-            <a:ext cx="2478024" cy="402336"/>
-          </a:xfrm>
-          <a:prstGeom prst="rect">
-            <a:avLst/>
-          </a:prstGeom>
-          <a:noFill/>
-        </p:spPr>
-        <p:txBody>
-          <a:bodyPr wrap="square" lIns="36576" tIns="18288" rIns="36576" bIns="18288" anchor="ctr">
-            <a:spAutoFit/>
-          </a:bodyPr>
-          <a:lstStyle/>
-          <a:p>
-            <a:pPr algn="l"/>
-            <a:r>
-              <a:rPr sz="1000" b="1" i="0">
-                <a:solidFill>
-                  <a:srgbClr val="000000"/>
-                </a:solidFill>
-                <a:latin typeface="맑은 고딕"/>
-              </a:rPr>
-              <a:t/>
-            </a:r>
-          </a:p>
-        </p:txBody>
-      </p:sp>
-      <p:sp>
-        <p:nvSpPr>
-          <p:cNvPr id="67" name="TextBox 66"/>
+          <p:cNvPr id="55" name="TextBox 54"/>
           <p:cNvSpPr txBox="1"/>
           <p:nvPr/>
         </p:nvSpPr>
@@ -17662,7 +17032,7 @@
       </p:sp>
       <p:sp>
         <p:nvSpPr>
-          <p:cNvPr id="68" name="Rectangle 67"/>
+          <p:cNvPr id="56" name="Rectangle 55"/>
           <p:cNvSpPr/>
           <p:nvPr/>
         </p:nvSpPr>
@@ -17708,7 +17078,7 @@
       </p:sp>
       <p:sp>
         <p:nvSpPr>
-          <p:cNvPr id="69" name="Rectangle 68"/>
+          <p:cNvPr id="57" name="Rectangle 56"/>
           <p:cNvSpPr/>
           <p:nvPr/>
         </p:nvSpPr>
@@ -17752,7 +17122,7 @@
       </p:sp>
       <p:sp>
         <p:nvSpPr>
-          <p:cNvPr id="70" name="Oval 69"/>
+          <p:cNvPr id="58" name="Oval 57"/>
           <p:cNvSpPr/>
           <p:nvPr/>
         </p:nvSpPr>
@@ -17805,42 +17175,7 @@
       </p:sp>
       <p:sp>
         <p:nvSpPr>
-          <p:cNvPr id="71" name="TextBox 70"/>
-          <p:cNvSpPr txBox="1"/>
-          <p:nvPr/>
-        </p:nvSpPr>
-        <p:spPr>
-          <a:xfrm>
-            <a:off x="9363456" y="2002536"/>
-            <a:ext cx="2478024" cy="402336"/>
-          </a:xfrm>
-          <a:prstGeom prst="rect">
-            <a:avLst/>
-          </a:prstGeom>
-          <a:noFill/>
-        </p:spPr>
-        <p:txBody>
-          <a:bodyPr wrap="square" lIns="36576" tIns="18288" rIns="36576" bIns="18288" anchor="ctr">
-            <a:spAutoFit/>
-          </a:bodyPr>
-          <a:lstStyle/>
-          <a:p>
-            <a:pPr algn="l"/>
-            <a:r>
-              <a:rPr sz="1000" b="1" i="0">
-                <a:solidFill>
-                  <a:srgbClr val="000000"/>
-                </a:solidFill>
-                <a:latin typeface="맑은 고딕"/>
-              </a:rPr>
-              <a:t/>
-            </a:r>
-          </a:p>
-        </p:txBody>
-      </p:sp>
-      <p:sp>
-        <p:nvSpPr>
-          <p:cNvPr id="72" name="TextBox 71"/>
+          <p:cNvPr id="59" name="TextBox 58"/>
           <p:cNvSpPr txBox="1"/>
           <p:nvPr/>
         </p:nvSpPr>
@@ -17875,7 +17210,7 @@
       </p:sp>
       <p:sp>
         <p:nvSpPr>
-          <p:cNvPr id="73" name="Rectangle 72"/>
+          <p:cNvPr id="60" name="Rectangle 59"/>
           <p:cNvSpPr/>
           <p:nvPr/>
         </p:nvSpPr>
@@ -17921,7 +17256,7 @@
       </p:sp>
       <p:sp>
         <p:nvSpPr>
-          <p:cNvPr id="74" name="Rectangle 73"/>
+          <p:cNvPr id="61" name="Rectangle 60"/>
           <p:cNvSpPr/>
           <p:nvPr/>
         </p:nvSpPr>
@@ -17965,7 +17300,7 @@
       </p:sp>
       <p:sp>
         <p:nvSpPr>
-          <p:cNvPr id="75" name="Oval 74"/>
+          <p:cNvPr id="62" name="Oval 61"/>
           <p:cNvSpPr/>
           <p:nvPr/>
         </p:nvSpPr>
@@ -18018,42 +17353,7 @@
       </p:sp>
       <p:sp>
         <p:nvSpPr>
-          <p:cNvPr id="76" name="TextBox 75"/>
-          <p:cNvSpPr txBox="1"/>
-          <p:nvPr/>
-        </p:nvSpPr>
-        <p:spPr>
-          <a:xfrm>
-            <a:off x="9363456" y="2478024"/>
-            <a:ext cx="2478024" cy="402336"/>
-          </a:xfrm>
-          <a:prstGeom prst="rect">
-            <a:avLst/>
-          </a:prstGeom>
-          <a:noFill/>
-        </p:spPr>
-        <p:txBody>
-          <a:bodyPr wrap="square" lIns="36576" tIns="18288" rIns="36576" bIns="18288" anchor="ctr">
-            <a:spAutoFit/>
-          </a:bodyPr>
-          <a:lstStyle/>
-          <a:p>
-            <a:pPr algn="l"/>
-            <a:r>
-              <a:rPr sz="1000" b="1" i="0">
-                <a:solidFill>
-                  <a:srgbClr val="000000"/>
-                </a:solidFill>
-                <a:latin typeface="맑은 고딕"/>
-              </a:rPr>
-              <a:t/>
-            </a:r>
-          </a:p>
-        </p:txBody>
-      </p:sp>
-      <p:sp>
-        <p:nvSpPr>
-          <p:cNvPr id="77" name="TextBox 76"/>
+          <p:cNvPr id="63" name="TextBox 62"/>
           <p:cNvSpPr txBox="1"/>
           <p:nvPr/>
         </p:nvSpPr>
@@ -18088,7 +17388,7 @@
       </p:sp>
       <p:sp>
         <p:nvSpPr>
-          <p:cNvPr id="78" name="Rectangle 77"/>
+          <p:cNvPr id="64" name="Rectangle 63"/>
           <p:cNvSpPr/>
           <p:nvPr/>
         </p:nvSpPr>
@@ -18134,7 +17434,7 @@
       </p:sp>
       <p:sp>
         <p:nvSpPr>
-          <p:cNvPr id="79" name="Rectangle 78"/>
+          <p:cNvPr id="65" name="Rectangle 64"/>
           <p:cNvSpPr/>
           <p:nvPr/>
         </p:nvSpPr>
@@ -18178,7 +17478,7 @@
       </p:sp>
       <p:sp>
         <p:nvSpPr>
-          <p:cNvPr id="80" name="Oval 79"/>
+          <p:cNvPr id="66" name="Oval 65"/>
           <p:cNvSpPr/>
           <p:nvPr/>
         </p:nvSpPr>
@@ -18231,42 +17531,7 @@
       </p:sp>
       <p:sp>
         <p:nvSpPr>
-          <p:cNvPr id="81" name="TextBox 80"/>
-          <p:cNvSpPr txBox="1"/>
-          <p:nvPr/>
-        </p:nvSpPr>
-        <p:spPr>
-          <a:xfrm>
-            <a:off x="9363456" y="2953512"/>
-            <a:ext cx="2478024" cy="402336"/>
-          </a:xfrm>
-          <a:prstGeom prst="rect">
-            <a:avLst/>
-          </a:prstGeom>
-          <a:noFill/>
-        </p:spPr>
-        <p:txBody>
-          <a:bodyPr wrap="square" lIns="36576" tIns="18288" rIns="36576" bIns="18288" anchor="ctr">
-            <a:spAutoFit/>
-          </a:bodyPr>
-          <a:lstStyle/>
-          <a:p>
-            <a:pPr algn="l"/>
-            <a:r>
-              <a:rPr sz="1000" b="1" i="0">
-                <a:solidFill>
-                  <a:srgbClr val="000000"/>
-                </a:solidFill>
-                <a:latin typeface="맑은 고딕"/>
-              </a:rPr>
-              <a:t/>
-            </a:r>
-          </a:p>
-        </p:txBody>
-      </p:sp>
-      <p:sp>
-        <p:nvSpPr>
-          <p:cNvPr id="82" name="TextBox 81"/>
+          <p:cNvPr id="67" name="TextBox 66"/>
           <p:cNvSpPr txBox="1"/>
           <p:nvPr/>
         </p:nvSpPr>
@@ -18301,7 +17566,7 @@
       </p:sp>
       <p:sp>
         <p:nvSpPr>
-          <p:cNvPr id="83" name="Rectangle 82"/>
+          <p:cNvPr id="68" name="Rectangle 67"/>
           <p:cNvSpPr/>
           <p:nvPr/>
         </p:nvSpPr>
@@ -18347,7 +17612,7 @@
       </p:sp>
       <p:sp>
         <p:nvSpPr>
-          <p:cNvPr id="84" name="Rectangle 83"/>
+          <p:cNvPr id="69" name="Rectangle 68"/>
           <p:cNvSpPr/>
           <p:nvPr/>
         </p:nvSpPr>
@@ -18391,7 +17656,7 @@
       </p:sp>
       <p:sp>
         <p:nvSpPr>
-          <p:cNvPr id="85" name="Oval 84"/>
+          <p:cNvPr id="70" name="Oval 69"/>
           <p:cNvSpPr/>
           <p:nvPr/>
         </p:nvSpPr>
@@ -18444,42 +17709,7 @@
       </p:sp>
       <p:sp>
         <p:nvSpPr>
-          <p:cNvPr id="86" name="TextBox 85"/>
-          <p:cNvSpPr txBox="1"/>
-          <p:nvPr/>
-        </p:nvSpPr>
-        <p:spPr>
-          <a:xfrm>
-            <a:off x="9363456" y="3429000"/>
-            <a:ext cx="2478024" cy="402336"/>
-          </a:xfrm>
-          <a:prstGeom prst="rect">
-            <a:avLst/>
-          </a:prstGeom>
-          <a:noFill/>
-        </p:spPr>
-        <p:txBody>
-          <a:bodyPr wrap="square" lIns="36576" tIns="18288" rIns="36576" bIns="18288" anchor="ctr">
-            <a:spAutoFit/>
-          </a:bodyPr>
-          <a:lstStyle/>
-          <a:p>
-            <a:pPr algn="l"/>
-            <a:r>
-              <a:rPr sz="1000" b="1" i="0">
-                <a:solidFill>
-                  <a:srgbClr val="000000"/>
-                </a:solidFill>
-                <a:latin typeface="맑은 고딕"/>
-              </a:rPr>
-              <a:t/>
-            </a:r>
-          </a:p>
-        </p:txBody>
-      </p:sp>
-      <p:sp>
-        <p:nvSpPr>
-          <p:cNvPr id="87" name="TextBox 86"/>
+          <p:cNvPr id="71" name="TextBox 70"/>
           <p:cNvSpPr txBox="1"/>
           <p:nvPr/>
         </p:nvSpPr>
@@ -18514,7 +17744,7 @@
       </p:sp>
       <p:sp>
         <p:nvSpPr>
-          <p:cNvPr id="88" name="Rectangle 87"/>
+          <p:cNvPr id="72" name="Rectangle 71"/>
           <p:cNvSpPr/>
           <p:nvPr/>
         </p:nvSpPr>
@@ -18560,7 +17790,7 @@
       </p:sp>
       <p:sp>
         <p:nvSpPr>
-          <p:cNvPr id="89" name="Rectangle 88"/>
+          <p:cNvPr id="73" name="Rectangle 72"/>
           <p:cNvSpPr/>
           <p:nvPr/>
         </p:nvSpPr>
@@ -18604,7 +17834,7 @@
       </p:sp>
       <p:sp>
         <p:nvSpPr>
-          <p:cNvPr id="90" name="Oval 89"/>
+          <p:cNvPr id="74" name="Oval 73"/>
           <p:cNvSpPr/>
           <p:nvPr/>
         </p:nvSpPr>
@@ -18657,42 +17887,7 @@
       </p:sp>
       <p:sp>
         <p:nvSpPr>
-          <p:cNvPr id="91" name="TextBox 90"/>
-          <p:cNvSpPr txBox="1"/>
-          <p:nvPr/>
-        </p:nvSpPr>
-        <p:spPr>
-          <a:xfrm>
-            <a:off x="9363456" y="3904487"/>
-            <a:ext cx="2478024" cy="402336"/>
-          </a:xfrm>
-          <a:prstGeom prst="rect">
-            <a:avLst/>
-          </a:prstGeom>
-          <a:noFill/>
-        </p:spPr>
-        <p:txBody>
-          <a:bodyPr wrap="square" lIns="36576" tIns="18288" rIns="36576" bIns="18288" anchor="ctr">
-            <a:spAutoFit/>
-          </a:bodyPr>
-          <a:lstStyle/>
-          <a:p>
-            <a:pPr algn="l"/>
-            <a:r>
-              <a:rPr sz="1000" b="1" i="0">
-                <a:solidFill>
-                  <a:srgbClr val="000000"/>
-                </a:solidFill>
-                <a:latin typeface="맑은 고딕"/>
-              </a:rPr>
-              <a:t/>
-            </a:r>
-          </a:p>
-        </p:txBody>
-      </p:sp>
-      <p:sp>
-        <p:nvSpPr>
-          <p:cNvPr id="92" name="TextBox 91"/>
+          <p:cNvPr id="75" name="TextBox 74"/>
           <p:cNvSpPr txBox="1"/>
           <p:nvPr/>
         </p:nvSpPr>
@@ -18727,7 +17922,7 @@
       </p:sp>
       <p:sp>
         <p:nvSpPr>
-          <p:cNvPr id="93" name="Rectangle 92"/>
+          <p:cNvPr id="76" name="Rectangle 75"/>
           <p:cNvSpPr/>
           <p:nvPr/>
         </p:nvSpPr>
@@ -18773,7 +17968,7 @@
       </p:sp>
       <p:sp>
         <p:nvSpPr>
-          <p:cNvPr id="94" name="Rectangle 93"/>
+          <p:cNvPr id="77" name="Rectangle 76"/>
           <p:cNvSpPr/>
           <p:nvPr/>
         </p:nvSpPr>
@@ -18817,7 +18012,7 @@
       </p:sp>
       <p:sp>
         <p:nvSpPr>
-          <p:cNvPr id="95" name="Oval 94"/>
+          <p:cNvPr id="78" name="Oval 77"/>
           <p:cNvSpPr/>
           <p:nvPr/>
         </p:nvSpPr>
@@ -18870,42 +18065,7 @@
       </p:sp>
       <p:sp>
         <p:nvSpPr>
-          <p:cNvPr id="96" name="TextBox 95"/>
-          <p:cNvSpPr txBox="1"/>
-          <p:nvPr/>
-        </p:nvSpPr>
-        <p:spPr>
-          <a:xfrm>
-            <a:off x="1234440" y="5029200"/>
-            <a:ext cx="2697479" cy="502920"/>
-          </a:xfrm>
-          <a:prstGeom prst="rect">
-            <a:avLst/>
-          </a:prstGeom>
-          <a:noFill/>
-        </p:spPr>
-        <p:txBody>
-          <a:bodyPr wrap="square" lIns="36576" tIns="18288" rIns="36576" bIns="18288" anchor="ctr">
-            <a:spAutoFit/>
-          </a:bodyPr>
-          <a:lstStyle/>
-          <a:p>
-            <a:pPr algn="l"/>
-            <a:r>
-              <a:rPr sz="1000" b="1" i="0">
-                <a:solidFill>
-                  <a:srgbClr val="000000"/>
-                </a:solidFill>
-                <a:latin typeface="맑은 고딕"/>
-              </a:rPr>
-              <a:t/>
-            </a:r>
-          </a:p>
-        </p:txBody>
-      </p:sp>
-      <p:sp>
-        <p:nvSpPr>
-          <p:cNvPr id="97" name="TextBox 96"/>
+          <p:cNvPr id="79" name="TextBox 78"/>
           <p:cNvSpPr txBox="1"/>
           <p:nvPr/>
         </p:nvSpPr>
@@ -18940,7 +18100,7 @@
       </p:sp>
       <p:sp>
         <p:nvSpPr>
-          <p:cNvPr id="98" name="Rectangle 97"/>
+          <p:cNvPr id="80" name="Rectangle 79"/>
           <p:cNvSpPr/>
           <p:nvPr/>
         </p:nvSpPr>
@@ -18986,7 +18146,7 @@
       </p:sp>
       <p:sp>
         <p:nvSpPr>
-          <p:cNvPr id="99" name="Rectangle 98"/>
+          <p:cNvPr id="81" name="Rectangle 80"/>
           <p:cNvSpPr/>
           <p:nvPr/>
         </p:nvSpPr>
@@ -19030,7 +18190,7 @@
       </p:sp>
       <p:sp>
         <p:nvSpPr>
-          <p:cNvPr id="100" name="Oval 99"/>
+          <p:cNvPr id="82" name="Oval 81"/>
           <p:cNvSpPr/>
           <p:nvPr/>
         </p:nvSpPr>
@@ -19083,42 +18243,7 @@
       </p:sp>
       <p:sp>
         <p:nvSpPr>
-          <p:cNvPr id="101" name="TextBox 100"/>
-          <p:cNvSpPr txBox="1"/>
-          <p:nvPr/>
-        </p:nvSpPr>
-        <p:spPr>
-          <a:xfrm>
-            <a:off x="5166359" y="5029200"/>
-            <a:ext cx="2697479" cy="502920"/>
-          </a:xfrm>
-          <a:prstGeom prst="rect">
-            <a:avLst/>
-          </a:prstGeom>
-          <a:noFill/>
-        </p:spPr>
-        <p:txBody>
-          <a:bodyPr wrap="square" lIns="36576" tIns="18288" rIns="36576" bIns="18288" anchor="ctr">
-            <a:spAutoFit/>
-          </a:bodyPr>
-          <a:lstStyle/>
-          <a:p>
-            <a:pPr algn="l"/>
-            <a:r>
-              <a:rPr sz="1000" b="1" i="0">
-                <a:solidFill>
-                  <a:srgbClr val="000000"/>
-                </a:solidFill>
-                <a:latin typeface="맑은 고딕"/>
-              </a:rPr>
-              <a:t/>
-            </a:r>
-          </a:p>
-        </p:txBody>
-      </p:sp>
-      <p:sp>
-        <p:nvSpPr>
-          <p:cNvPr id="102" name="TextBox 101"/>
+          <p:cNvPr id="83" name="TextBox 82"/>
           <p:cNvSpPr txBox="1"/>
           <p:nvPr/>
         </p:nvSpPr>
@@ -19153,7 +18278,7 @@
       </p:sp>
       <p:sp>
         <p:nvSpPr>
-          <p:cNvPr id="103" name="Rectangle 102"/>
+          <p:cNvPr id="84" name="Rectangle 83"/>
           <p:cNvSpPr/>
           <p:nvPr/>
         </p:nvSpPr>
@@ -19199,7 +18324,7 @@
       </p:sp>
       <p:sp>
         <p:nvSpPr>
-          <p:cNvPr id="104" name="Rectangle 103"/>
+          <p:cNvPr id="85" name="Rectangle 84"/>
           <p:cNvSpPr/>
           <p:nvPr/>
         </p:nvSpPr>
@@ -19243,7 +18368,7 @@
       </p:sp>
       <p:sp>
         <p:nvSpPr>
-          <p:cNvPr id="105" name="Oval 104"/>
+          <p:cNvPr id="86" name="Oval 85"/>
           <p:cNvSpPr/>
           <p:nvPr/>
         </p:nvSpPr>
@@ -19296,42 +18421,7 @@
       </p:sp>
       <p:sp>
         <p:nvSpPr>
-          <p:cNvPr id="106" name="TextBox 105"/>
-          <p:cNvSpPr txBox="1"/>
-          <p:nvPr/>
-        </p:nvSpPr>
-        <p:spPr>
-          <a:xfrm>
-            <a:off x="9098280" y="5029200"/>
-            <a:ext cx="2697479" cy="502920"/>
-          </a:xfrm>
-          <a:prstGeom prst="rect">
-            <a:avLst/>
-          </a:prstGeom>
-          <a:noFill/>
-        </p:spPr>
-        <p:txBody>
-          <a:bodyPr wrap="square" lIns="36576" tIns="18288" rIns="36576" bIns="18288" anchor="ctr">
-            <a:spAutoFit/>
-          </a:bodyPr>
-          <a:lstStyle/>
-          <a:p>
-            <a:pPr algn="l"/>
-            <a:r>
-              <a:rPr sz="1000" b="1" i="0">
-                <a:solidFill>
-                  <a:srgbClr val="000000"/>
-                </a:solidFill>
-                <a:latin typeface="맑은 고딕"/>
-              </a:rPr>
-              <a:t/>
-            </a:r>
-          </a:p>
-        </p:txBody>
-      </p:sp>
-      <p:sp>
-        <p:nvSpPr>
-          <p:cNvPr id="107" name="TextBox 106"/>
+          <p:cNvPr id="87" name="TextBox 86"/>
           <p:cNvSpPr txBox="1"/>
           <p:nvPr/>
         </p:nvSpPr>
@@ -19366,7 +18456,7 @@
       </p:sp>
       <p:sp>
         <p:nvSpPr>
-          <p:cNvPr id="108" name="Rectangle 107"/>
+          <p:cNvPr id="88" name="Rectangle 87"/>
           <p:cNvSpPr/>
           <p:nvPr/>
         </p:nvSpPr>
@@ -19412,7 +18502,7 @@
       </p:sp>
       <p:sp>
         <p:nvSpPr>
-          <p:cNvPr id="109" name="Rectangle 108"/>
+          <p:cNvPr id="89" name="Rectangle 88"/>
           <p:cNvSpPr/>
           <p:nvPr/>
         </p:nvSpPr>
@@ -19456,7 +18546,7 @@
       </p:sp>
       <p:sp>
         <p:nvSpPr>
-          <p:cNvPr id="110" name="Oval 109"/>
+          <p:cNvPr id="90" name="Oval 89"/>
           <p:cNvSpPr/>
           <p:nvPr/>
         </p:nvSpPr>
@@ -19509,42 +18599,7 @@
       </p:sp>
       <p:sp>
         <p:nvSpPr>
-          <p:cNvPr id="111" name="TextBox 110"/>
-          <p:cNvSpPr txBox="1"/>
-          <p:nvPr/>
-        </p:nvSpPr>
-        <p:spPr>
-          <a:xfrm>
-            <a:off x="1234440" y="5669280"/>
-            <a:ext cx="2697479" cy="502920"/>
-          </a:xfrm>
-          <a:prstGeom prst="rect">
-            <a:avLst/>
-          </a:prstGeom>
-          <a:noFill/>
-        </p:spPr>
-        <p:txBody>
-          <a:bodyPr wrap="square" lIns="36576" tIns="18288" rIns="36576" bIns="18288" anchor="ctr">
-            <a:spAutoFit/>
-          </a:bodyPr>
-          <a:lstStyle/>
-          <a:p>
-            <a:pPr algn="l"/>
-            <a:r>
-              <a:rPr sz="1000" b="1" i="0">
-                <a:solidFill>
-                  <a:srgbClr val="000000"/>
-                </a:solidFill>
-                <a:latin typeface="맑은 고딕"/>
-              </a:rPr>
-              <a:t/>
-            </a:r>
-          </a:p>
-        </p:txBody>
-      </p:sp>
-      <p:sp>
-        <p:nvSpPr>
-          <p:cNvPr id="112" name="TextBox 111"/>
+          <p:cNvPr id="91" name="TextBox 90"/>
           <p:cNvSpPr txBox="1"/>
           <p:nvPr/>
         </p:nvSpPr>
@@ -19579,7 +18634,7 @@
       </p:sp>
       <p:sp>
         <p:nvSpPr>
-          <p:cNvPr id="113" name="Rectangle 112"/>
+          <p:cNvPr id="92" name="Rectangle 91"/>
           <p:cNvSpPr/>
           <p:nvPr/>
         </p:nvSpPr>
@@ -19625,7 +18680,7 @@
       </p:sp>
       <p:sp>
         <p:nvSpPr>
-          <p:cNvPr id="114" name="Rectangle 113"/>
+          <p:cNvPr id="93" name="Rectangle 92"/>
           <p:cNvSpPr/>
           <p:nvPr/>
         </p:nvSpPr>
@@ -19669,7 +18724,7 @@
       </p:sp>
       <p:sp>
         <p:nvSpPr>
-          <p:cNvPr id="115" name="Oval 114"/>
+          <p:cNvPr id="94" name="Oval 93"/>
           <p:cNvSpPr/>
           <p:nvPr/>
         </p:nvSpPr>
@@ -19722,42 +18777,7 @@
       </p:sp>
       <p:sp>
         <p:nvSpPr>
-          <p:cNvPr id="116" name="TextBox 115"/>
-          <p:cNvSpPr txBox="1"/>
-          <p:nvPr/>
-        </p:nvSpPr>
-        <p:spPr>
-          <a:xfrm>
-            <a:off x="5166359" y="5669280"/>
-            <a:ext cx="2697479" cy="502920"/>
-          </a:xfrm>
-          <a:prstGeom prst="rect">
-            <a:avLst/>
-          </a:prstGeom>
-          <a:noFill/>
-        </p:spPr>
-        <p:txBody>
-          <a:bodyPr wrap="square" lIns="36576" tIns="18288" rIns="36576" bIns="18288" anchor="ctr">
-            <a:spAutoFit/>
-          </a:bodyPr>
-          <a:lstStyle/>
-          <a:p>
-            <a:pPr algn="l"/>
-            <a:r>
-              <a:rPr sz="1000" b="1" i="0">
-                <a:solidFill>
-                  <a:srgbClr val="000000"/>
-                </a:solidFill>
-                <a:latin typeface="맑은 고딕"/>
-              </a:rPr>
-              <a:t/>
-            </a:r>
-          </a:p>
-        </p:txBody>
-      </p:sp>
-      <p:sp>
-        <p:nvSpPr>
-          <p:cNvPr id="117" name="TextBox 116"/>
+          <p:cNvPr id="95" name="TextBox 94"/>
           <p:cNvSpPr txBox="1"/>
           <p:nvPr/>
         </p:nvSpPr>
@@ -19792,7 +18812,7 @@
       </p:sp>
       <p:sp>
         <p:nvSpPr>
-          <p:cNvPr id="118" name="Rectangle 117"/>
+          <p:cNvPr id="96" name="Rectangle 95"/>
           <p:cNvSpPr/>
           <p:nvPr/>
         </p:nvSpPr>
@@ -19838,7 +18858,7 @@
       </p:sp>
       <p:sp>
         <p:nvSpPr>
-          <p:cNvPr id="119" name="Rectangle 118"/>
+          <p:cNvPr id="97" name="Rectangle 96"/>
           <p:cNvSpPr/>
           <p:nvPr/>
         </p:nvSpPr>
@@ -19882,7 +18902,7 @@
       </p:sp>
       <p:sp>
         <p:nvSpPr>
-          <p:cNvPr id="120" name="Oval 119"/>
+          <p:cNvPr id="98" name="Oval 97"/>
           <p:cNvSpPr/>
           <p:nvPr/>
         </p:nvSpPr>
@@ -19935,42 +18955,7 @@
       </p:sp>
       <p:sp>
         <p:nvSpPr>
-          <p:cNvPr id="121" name="TextBox 120"/>
-          <p:cNvSpPr txBox="1"/>
-          <p:nvPr/>
-        </p:nvSpPr>
-        <p:spPr>
-          <a:xfrm>
-            <a:off x="9098280" y="5669280"/>
-            <a:ext cx="2697479" cy="502920"/>
-          </a:xfrm>
-          <a:prstGeom prst="rect">
-            <a:avLst/>
-          </a:prstGeom>
-          <a:noFill/>
-        </p:spPr>
-        <p:txBody>
-          <a:bodyPr wrap="square" lIns="36576" tIns="18288" rIns="36576" bIns="18288" anchor="ctr">
-            <a:spAutoFit/>
-          </a:bodyPr>
-          <a:lstStyle/>
-          <a:p>
-            <a:pPr algn="l"/>
-            <a:r>
-              <a:rPr sz="1000" b="1" i="0">
-                <a:solidFill>
-                  <a:srgbClr val="000000"/>
-                </a:solidFill>
-                <a:latin typeface="맑은 고딕"/>
-              </a:rPr>
-              <a:t/>
-            </a:r>
-          </a:p>
-        </p:txBody>
-      </p:sp>
-      <p:sp>
-        <p:nvSpPr>
-          <p:cNvPr id="122" name="TextBox 121"/>
+          <p:cNvPr id="99" name="TextBox 98"/>
           <p:cNvSpPr txBox="1"/>
           <p:nvPr/>
         </p:nvSpPr>
@@ -20005,7 +18990,7 @@
       </p:sp>
       <p:sp>
         <p:nvSpPr>
-          <p:cNvPr id="123" name="TextBox 122"/>
+          <p:cNvPr id="100" name="TextBox 99"/>
           <p:cNvSpPr txBox="1"/>
           <p:nvPr/>
         </p:nvSpPr>

</xml_diff>